<commit_message>
Added small fix to presentation
Added a slide to the pptx
</commit_message>
<xml_diff>
--- a/Presentation/GroupReflection.pptx
+++ b/Presentation/GroupReflection.pptx
@@ -6,11 +6,12 @@
   </p:sldMasterIdLst>
   <p:sldIdLst>
     <p:sldId id="256" r:id="rId2"/>
-    <p:sldId id="258" r:id="rId3"/>
-    <p:sldId id="259" r:id="rId4"/>
-    <p:sldId id="260" r:id="rId5"/>
-    <p:sldId id="261" r:id="rId6"/>
-    <p:sldId id="262" r:id="rId7"/>
+    <p:sldId id="263" r:id="rId3"/>
+    <p:sldId id="258" r:id="rId4"/>
+    <p:sldId id="259" r:id="rId5"/>
+    <p:sldId id="260" r:id="rId6"/>
+    <p:sldId id="261" r:id="rId7"/>
+    <p:sldId id="262" r:id="rId8"/>
   </p:sldIdLst>
   <p:sldSz cx="12192000" cy="6858000"/>
   <p:notesSz cx="6858000" cy="9144000"/>
@@ -3458,7 +3459,7 @@
           <p:cNvPr id="2" name="Title 1">
             <a:extLst>
               <a:ext uri="{FF2B5EF4-FFF2-40B4-BE49-F238E27FC236}">
-                <a16:creationId xmlns:a16="http://schemas.microsoft.com/office/drawing/2014/main" id="{61D2BD73-CF0E-DA04-6EAB-591AC6447E5F}"/>
+                <a16:creationId xmlns:a16="http://schemas.microsoft.com/office/drawing/2014/main" id="{B9B11949-BA89-18F7-E82A-216032FEB00B}"/>
               </a:ext>
             </a:extLst>
           </p:cNvPr>
@@ -3476,7 +3477,7 @@
           <a:p>
             <a:r>
               <a:rPr lang="en-MX" dirty="0"/>
-              <a:t>Challenges and how we solved them</a:t>
+              <a:t>Our Strategy</a:t>
             </a:r>
           </a:p>
         </p:txBody>
@@ -3486,7 +3487,7 @@
           <p:cNvPr id="3" name="Content Placeholder 2">
             <a:extLst>
               <a:ext uri="{FF2B5EF4-FFF2-40B4-BE49-F238E27FC236}">
-                <a16:creationId xmlns:a16="http://schemas.microsoft.com/office/drawing/2014/main" id="{3805363E-B15D-32E5-7661-CBF5F1D4893D}"/>
+                <a16:creationId xmlns:a16="http://schemas.microsoft.com/office/drawing/2014/main" id="{769CAE02-006D-717E-26BB-680592C9E8EC}"/>
               </a:ext>
             </a:extLst>
           </p:cNvPr>
@@ -3499,67 +3500,28 @@
         </p:nvSpPr>
         <p:spPr/>
         <p:txBody>
-          <a:bodyPr>
-            <a:normAutofit fontScale="85000" lnSpcReduction="20000"/>
-          </a:bodyPr>
-          <a:lstStyle/>
-          <a:p>
-            <a:r>
-              <a:rPr lang="en-MX" b="1" dirty="0"/>
-              <a:t>GitHub organization:</a:t>
-            </a:r>
-            <a:r>
-              <a:rPr lang="en-MX" dirty="0"/>
-              <a:t> Early on, issues, branches, and commits were inconsistent. We solved it by establishing naming conventions and assigning specific issues to each member before writing any code.</a:t>
-            </a:r>
-          </a:p>
-          <a:p>
-            <a:r>
-              <a:rPr lang="en-MX" b="1" dirty="0"/>
-              <a:t>Full-stack development from scratch:</a:t>
-            </a:r>
-            <a:r>
-              <a:rPr lang="en-MX" dirty="0"/>
-              <a:t> None of us had prior experience connecting a frontend to a REST API backed by a relational database. We tackled it incrementally, schema first, then endpoints, then the frontend consuming the API.</a:t>
-            </a:r>
-          </a:p>
-          <a:p>
-            <a:r>
-              <a:rPr lang="en-MX" b="1" dirty="0"/>
-              <a:t>2.5D Raycasting engine:</a:t>
-            </a:r>
-            <a:r>
-              <a:rPr lang="en-MX" dirty="0"/>
-              <a:t> Building the graphics engine from scratch in canvas was the highest technical barrier. We studied the DDA (</a:t>
-            </a:r>
-            <a:r>
-              <a:rPr lang="en-MX" i="1" dirty="0"/>
-              <a:t>Digital Differential Analysis)</a:t>
-            </a:r>
-            <a:r>
-              <a:rPr lang="en-MX" dirty="0"/>
-              <a:t> raycasting algorithm and extended it to support sprites, multiple sky/floor textures, and weather conditions.</a:t>
-            </a:r>
-          </a:p>
-          <a:p>
-            <a:r>
-              <a:rPr lang="en-MX" b="1" dirty="0"/>
-              <a:t>CPU card AI:</a:t>
-            </a:r>
-            <a:r>
-              <a:rPr lang="en-MX" dirty="0"/>
-              <a:t> Making opponents feel meaningfully different required designing a situational decision system. Each personality evaluates distance, position, and health before deciding whether and which card to play.</a:t>
-            </a:r>
-          </a:p>
-          <a:p>
-            <a:endParaRPr lang="en-MX" dirty="0"/>
+          <a:bodyPr/>
+          <a:lstStyle/>
+          <a:p>
+            <a:r>
+              <a:rPr lang="en-US" dirty="0"/>
+              <a:t>During this software construction process, and since our schedule in Tecnológico de Monterrey is managed by weeks, we opted for week-long sprints using the SCRUM methodology. SCRUM is an agile methodology that allows us to be transparent, apply deep and concentrated inspection into the work we are delivering, and adapt to challenges that may arise during the process. This methodology also allows us to have weekly meetings with a product owner (in this case, teachers) to make sure we are advancing at a steady pace, delivering based on how critical the work is, and also correct our path if we </a:t>
+            </a:r>
+            <a:r>
+              <a:rPr lang="en-US" dirty="0" err="1"/>
+              <a:t>missailing</a:t>
+            </a:r>
+            <a:r>
+              <a:rPr lang="en-US" dirty="0"/>
+              <a:t> from the original idea or from what the product owners want.</a:t>
+            </a:r>
           </a:p>
         </p:txBody>
       </p:sp>
     </p:spTree>
     <p:extLst>
       <p:ext uri="{BB962C8B-B14F-4D97-AF65-F5344CB8AC3E}">
-        <p14:creationId xmlns:p14="http://schemas.microsoft.com/office/powerpoint/2010/main" val="3435247697"/>
+        <p14:creationId xmlns:p14="http://schemas.microsoft.com/office/powerpoint/2010/main" val="1458959221"/>
       </p:ext>
     </p:extLst>
   </p:cSld>
@@ -3591,7 +3553,7 @@
           <p:cNvPr id="2" name="Title 1">
             <a:extLst>
               <a:ext uri="{FF2B5EF4-FFF2-40B4-BE49-F238E27FC236}">
-                <a16:creationId xmlns:a16="http://schemas.microsoft.com/office/drawing/2014/main" id="{411E50FE-D362-2F45-8C81-F0F9BFA03800}"/>
+                <a16:creationId xmlns:a16="http://schemas.microsoft.com/office/drawing/2014/main" id="{61D2BD73-CF0E-DA04-6EAB-591AC6447E5F}"/>
               </a:ext>
             </a:extLst>
           </p:cNvPr>
@@ -3609,7 +3571,7 @@
           <a:p>
             <a:r>
               <a:rPr lang="en-MX" dirty="0"/>
-              <a:t>Key Lessons Learned	</a:t>
+              <a:t>Challenges and how we solved them</a:t>
             </a:r>
           </a:p>
         </p:txBody>
@@ -3619,7 +3581,7 @@
           <p:cNvPr id="3" name="Content Placeholder 2">
             <a:extLst>
               <a:ext uri="{FF2B5EF4-FFF2-40B4-BE49-F238E27FC236}">
-                <a16:creationId xmlns:a16="http://schemas.microsoft.com/office/drawing/2014/main" id="{829B2364-F392-E08B-9A55-9E70221BAC05}"/>
+                <a16:creationId xmlns:a16="http://schemas.microsoft.com/office/drawing/2014/main" id="{3805363E-B15D-32E5-7661-CBF5F1D4893D}"/>
               </a:ext>
             </a:extLst>
           </p:cNvPr>
@@ -3632,30 +3594,56 @@
         </p:nvSpPr>
         <p:spPr/>
         <p:txBody>
-          <a:bodyPr/>
-          <a:lstStyle/>
-          <a:p>
+          <a:bodyPr>
+            <a:normAutofit fontScale="85000" lnSpcReduction="20000"/>
+          </a:bodyPr>
+          <a:lstStyle/>
+          <a:p>
+            <a:r>
+              <a:rPr lang="en-MX" b="1" dirty="0"/>
+              <a:t>GitHub organization:</a:t>
+            </a:r>
             <a:r>
               <a:rPr lang="en-MX" dirty="0"/>
-              <a:t>A structured GitHub workflow (issues → branch → merge) dramatically improves coordination even in small teams.</a:t>
-            </a:r>
-          </a:p>
-          <a:p>
+              <a:t> Early on, issues, branches, and commits were inconsistent. We solved it by establishing naming conventions and assigning specific issues to each member before writing any code.</a:t>
+            </a:r>
+          </a:p>
+          <a:p>
+            <a:r>
+              <a:rPr lang="en-MX" b="1" dirty="0"/>
+              <a:t>Full-stack development from scratch:</a:t>
+            </a:r>
             <a:r>
               <a:rPr lang="en-MX" dirty="0"/>
-              <a:t>Separating frontend, backend, and database concerns from day one allows parallel development and cleaner code.</a:t>
-            </a:r>
-          </a:p>
-          <a:p>
+              <a:t> None of us had prior experience connecting a frontend to a REST API backed by a relational database. We tackled it incrementally, schema first, then endpoints, then the frontend consuming the API.</a:t>
+            </a:r>
+          </a:p>
+          <a:p>
+            <a:r>
+              <a:rPr lang="en-MX" b="1" dirty="0"/>
+              <a:t>2.5D Raycasting engine:</a:t>
+            </a:r>
             <a:r>
               <a:rPr lang="en-MX" dirty="0"/>
-              <a:t>Game design and programming constantly feed each other. Ideas on paper always change once you implement them.</a:t>
-            </a:r>
-          </a:p>
-          <a:p>
+              <a:t> Building the graphics engine from scratch in canvas was the highest technical barrier. We studied the DDA (</a:t>
+            </a:r>
+            <a:r>
+              <a:rPr lang="en-MX" i="1" dirty="0"/>
+              <a:t>Digital Differential Analysis)</a:t>
+            </a:r>
             <a:r>
               <a:rPr lang="en-MX" dirty="0"/>
-              <a:t>Documenting early (GDD, SRS) prevents repeated design discussions during development.</a:t>
+              <a:t> raycasting algorithm and extended it to support sprites, multiple sky/floor textures, and weather conditions.</a:t>
+            </a:r>
+          </a:p>
+          <a:p>
+            <a:r>
+              <a:rPr lang="en-MX" b="1" dirty="0"/>
+              <a:t>CPU card AI:</a:t>
+            </a:r>
+            <a:r>
+              <a:rPr lang="en-MX" dirty="0"/>
+              <a:t> Making opponents feel meaningfully different required designing a situational decision system. Each personality evaluates distance, position, and health before deciding whether and which card to play.</a:t>
             </a:r>
           </a:p>
           <a:p>
@@ -3666,7 +3654,7 @@
     </p:spTree>
     <p:extLst>
       <p:ext uri="{BB962C8B-B14F-4D97-AF65-F5344CB8AC3E}">
-        <p14:creationId xmlns:p14="http://schemas.microsoft.com/office/powerpoint/2010/main" val="3922487364"/>
+        <p14:creationId xmlns:p14="http://schemas.microsoft.com/office/powerpoint/2010/main" val="3435247697"/>
       </p:ext>
     </p:extLst>
   </p:cSld>
@@ -3698,6 +3686,113 @@
           <p:cNvPr id="2" name="Title 1">
             <a:extLst>
               <a:ext uri="{FF2B5EF4-FFF2-40B4-BE49-F238E27FC236}">
+                <a16:creationId xmlns:a16="http://schemas.microsoft.com/office/drawing/2014/main" id="{411E50FE-D362-2F45-8C81-F0F9BFA03800}"/>
+              </a:ext>
+            </a:extLst>
+          </p:cNvPr>
+          <p:cNvSpPr>
+            <a:spLocks noGrp="1"/>
+          </p:cNvSpPr>
+          <p:nvPr>
+            <p:ph type="title"/>
+          </p:nvPr>
+        </p:nvSpPr>
+        <p:spPr/>
+        <p:txBody>
+          <a:bodyPr/>
+          <a:lstStyle/>
+          <a:p>
+            <a:r>
+              <a:rPr lang="en-MX" dirty="0"/>
+              <a:t>Key Lessons Learned	</a:t>
+            </a:r>
+          </a:p>
+        </p:txBody>
+      </p:sp>
+      <p:sp>
+        <p:nvSpPr>
+          <p:cNvPr id="3" name="Content Placeholder 2">
+            <a:extLst>
+              <a:ext uri="{FF2B5EF4-FFF2-40B4-BE49-F238E27FC236}">
+                <a16:creationId xmlns:a16="http://schemas.microsoft.com/office/drawing/2014/main" id="{829B2364-F392-E08B-9A55-9E70221BAC05}"/>
+              </a:ext>
+            </a:extLst>
+          </p:cNvPr>
+          <p:cNvSpPr>
+            <a:spLocks noGrp="1"/>
+          </p:cNvSpPr>
+          <p:nvPr>
+            <p:ph idx="1"/>
+          </p:nvPr>
+        </p:nvSpPr>
+        <p:spPr/>
+        <p:txBody>
+          <a:bodyPr/>
+          <a:lstStyle/>
+          <a:p>
+            <a:r>
+              <a:rPr lang="en-MX" dirty="0"/>
+              <a:t>A structured GitHub workflow (issues → branch → merge) dramatically improves coordination even in small teams.</a:t>
+            </a:r>
+          </a:p>
+          <a:p>
+            <a:r>
+              <a:rPr lang="en-MX" dirty="0"/>
+              <a:t>Separating frontend, backend, and database concerns from day one allows parallel development and cleaner code.</a:t>
+            </a:r>
+          </a:p>
+          <a:p>
+            <a:r>
+              <a:rPr lang="en-MX" dirty="0"/>
+              <a:t>Game design and programming constantly feed each other. Ideas on paper always change once you implement them.</a:t>
+            </a:r>
+          </a:p>
+          <a:p>
+            <a:r>
+              <a:rPr lang="en-MX" dirty="0"/>
+              <a:t>Documenting early (GDD, SRS) prevents repeated design discussions during development.</a:t>
+            </a:r>
+          </a:p>
+          <a:p>
+            <a:endParaRPr lang="en-MX" dirty="0"/>
+          </a:p>
+        </p:txBody>
+      </p:sp>
+    </p:spTree>
+    <p:extLst>
+      <p:ext uri="{BB962C8B-B14F-4D97-AF65-F5344CB8AC3E}">
+        <p14:creationId xmlns:p14="http://schemas.microsoft.com/office/powerpoint/2010/main" val="3922487364"/>
+      </p:ext>
+    </p:extLst>
+  </p:cSld>
+  <p:clrMapOvr>
+    <a:masterClrMapping/>
+  </p:clrMapOvr>
+</p:sld>
+</file>
+
+<file path=ppt/slides/slide5.xml><?xml version="1.0" encoding="utf-8"?>
+<p:sld xmlns:a="http://schemas.openxmlformats.org/drawingml/2006/main" xmlns:r="http://schemas.openxmlformats.org/officeDocument/2006/relationships" xmlns:p="http://schemas.openxmlformats.org/presentationml/2006/main">
+  <p:cSld>
+    <p:spTree>
+      <p:nvGrpSpPr>
+        <p:cNvPr id="1" name=""/>
+        <p:cNvGrpSpPr/>
+        <p:nvPr/>
+      </p:nvGrpSpPr>
+      <p:grpSpPr>
+        <a:xfrm>
+          <a:off x="0" y="0"/>
+          <a:ext cx="0" cy="0"/>
+          <a:chOff x="0" y="0"/>
+          <a:chExt cx="0" cy="0"/>
+        </a:xfrm>
+      </p:grpSpPr>
+      <p:sp>
+        <p:nvSpPr>
+          <p:cNvPr id="2" name="Title 1">
+            <a:extLst>
+              <a:ext uri="{FF2B5EF4-FFF2-40B4-BE49-F238E27FC236}">
                 <a16:creationId xmlns:a16="http://schemas.microsoft.com/office/drawing/2014/main" id="{AE4FE5C6-44DD-9E30-9639-ABD7E9072AAC}"/>
               </a:ext>
             </a:extLst>
@@ -3762,7 +3857,7 @@
 </p:sld>
 </file>
 
-<file path=ppt/slides/slide5.xml><?xml version="1.0" encoding="utf-8"?>
+<file path=ppt/slides/slide6.xml><?xml version="1.0" encoding="utf-8"?>
 <p:sld xmlns:a="http://schemas.openxmlformats.org/drawingml/2006/main" xmlns:r="http://schemas.openxmlformats.org/officeDocument/2006/relationships" xmlns:p="http://schemas.openxmlformats.org/presentationml/2006/main">
   <p:cSld>
     <p:spTree>
@@ -3862,7 +3957,7 @@
 </p:sld>
 </file>
 
-<file path=ppt/slides/slide6.xml><?xml version="1.0" encoding="utf-8"?>
+<file path=ppt/slides/slide7.xml><?xml version="1.0" encoding="utf-8"?>
 <p:sld xmlns:a="http://schemas.openxmlformats.org/drawingml/2006/main" xmlns:r="http://schemas.openxmlformats.org/officeDocument/2006/relationships" xmlns:p="http://schemas.openxmlformats.org/presentationml/2006/main">
   <p:cSld>
     <p:spTree>

</xml_diff>